<commit_message>
Expand healthcare briefing to all eligible firms and annual DuPont contributions
</commit_message>
<xml_diff>
--- a/presentations/homework5_team/Homework5_Team_10_Slides.pptx
+++ b/presentations/homework5_team/Homework5_Team_10_Slides.pptx
@@ -721,7 +721,7 @@
           <a:lstStyle/>
           <a:p>
             <a:r>
-              <a:t>2025 Amgen ROE: $7.711bn / $8.658bn = 89.06%. Its net income/assets is about 8.51%, versus IDEXX about 31.62%. The comparison is accounting ROA, not operating income/assets. ROE = margin × turnover × multiplier. Equity multipliers are not debt-to-equity ratios. Do not infer why equity became small without a rollforward. HCA provides a warning case: positive income $6.784bn / negative equity $6.027bn = negative 112.56% ROE, which does not indicate a net loss.</a:t>
+              <a:t>255 eligible company-years; 43 distinct firms. Missing or flagged years are not imputed. Scatter x = net income / year-end assets; y = net income / year-end equity. Their ratio is the equity multiplier. This is a mechanical relationship, not an independent causal test. A company appears in multiple panels: observations are dependent. Full ticker-by-year values are in roe_all_years_percent.csv and all_company_years.png. The previous Amgen/IDEXX pair was illustrative, not the entire analyzed sample.</a:t>
             </a:r>
           </a:p>
         </p:txBody>
@@ -791,12 +791,7 @@
           <a:lstStyle/>
           <a:p>
             <a:r>
-              <a:t>Source: Pfizer 2023 10-K, https://www.sec.gov/Archives/edgar/data/78003/000007800324000039/0000078003-24-000039.txt</a:t>
-            </a:r>
-          </a:p>
-          <a:p>
-            <a:r>
-              <a:t>The filing states reduced COVID-product demand has led to reduced revenues/excess inventory and significant Paxlovid/Comirnaty write-offs in 2023. The chart uses current recovered year-end values, not older average-balance ratios. Contributions average all six orders of replacing the three DuPont factors and sum exactly to the observed ROE change. The acquisition of Seagen is an additional asset-base issue. The graph does not estimate how many ROE points were caused by a particular disclosed event.</a:t>
+              <a:t>For each firm and consecutive year, replace margin, turnover and multiplier in all six possible orders; average each factor’s incremental contribution. Then average firm contributions equally across the same 40 companies. Contributions sum exactly to the change in mean ROE. This is NOT a decomposition of median ROE. The 2021 increase is predominantly margin; all three components contribute negatively in 2023. Firm-level contributions and aggregate means are supplied as CSV. To investigate causes, use company disclosures: Pfizer 2023 discusses lower COVID demand, inventory write-offs and Seagen acquisition, but this does not establish the sector-wide causal effect. Source: https://www.sec.gov/Archives/edgar/data/78003/000007800324000039/0000078003-24-000039.txt</a:t>
             </a:r>
           </a:p>
         </p:txBody>
@@ -4657,7 +4652,7 @@
       </p:sp>
       <p:pic>
         <p:nvPicPr>
-          <p:cNvPr id="3" name="Picture 2" descr="04_roe_trends.png"/>
+          <p:cNvPr id="3" name="Picture 2" descr="four_components_all_years.png"/>
           <p:cNvPicPr>
             <a:picLocks noChangeAspect="1"/>
           </p:cNvPicPr>
@@ -4671,8 +4666,8 @@
         </p:blipFill>
         <p:spPr>
           <a:xfrm>
-            <a:off x="365760" y="1234440"/>
-            <a:ext cx="7498079" cy="3708954"/>
+            <a:off x="378822" y="1234440"/>
+            <a:ext cx="7471954" cy="4754880"/>
           </a:xfrm>
           <a:prstGeom prst="rect">
             <a:avLst/>
@@ -4874,14 +4869,14 @@
               </a:defRPr>
             </a:pPr>
             <a:r>
-              <a:t>A higher ROE can reverse the ranking of asset returns</a:t>
+              <a:t>Look across every year before selecting individual examples</a:t>
             </a:r>
           </a:p>
         </p:txBody>
       </p:sp>
       <p:pic>
         <p:nvPicPr>
-          <p:cNvPr id="3" name="Picture 2" descr="roe_reversal.png"/>
+          <p:cNvPr id="3" name="Picture 2" descr="all_year_scatter.png"/>
           <p:cNvPicPr>
             <a:picLocks noChangeAspect="1"/>
           </p:cNvPicPr>
@@ -4896,7 +4891,7 @@
         <p:spPr>
           <a:xfrm>
             <a:off x="365760" y="1234440"/>
-            <a:ext cx="7498079" cy="3749039"/>
+            <a:ext cx="7498079" cy="4373880"/>
           </a:xfrm>
           <a:prstGeom prst="rect">
             <a:avLst/>
@@ -4936,7 +4931,7 @@
               </a:defRPr>
             </a:pPr>
             <a:r>
-              <a:t>Amgen: equity multiplier 10.46×.</a:t>
+              <a:t>All 43 eligible companies contribute available observations.</a:t>
             </a:r>
           </a:p>
           <a:p>
@@ -4951,7 +4946,7 @@
               </a:defRPr>
             </a:pPr>
             <a:r>
-              <a:t>IDEXX: equity multiplier 2.09×.</a:t>
+              <a:t>Each dot is one company in that year.</a:t>
             </a:r>
           </a:p>
           <a:p>
@@ -4966,7 +4961,7 @@
               </a:defRPr>
             </a:pPr>
             <a:r>
-              <a:t>Question: is the return driven by earnings, asset use, or the equity base?</a:t>
+              <a:t>A high ROE can reflect a small equity base, not just strong asset returns.</a:t>
             </a:r>
           </a:p>
         </p:txBody>
@@ -5004,7 +4999,7 @@
               </a:defRPr>
             </a:pPr>
             <a:r>
-              <a:t>2025 year-end basis • Illustrative selected cases; not an investment ranking</a:t>
+              <a:t>All available eligible firm-years • Same year-end accounting basis • No outliers hidden</a:t>
             </a:r>
           </a:p>
         </p:txBody>
@@ -5098,14 +5093,14 @@
               </a:defRPr>
             </a:pPr>
             <a:r>
-              <a:t>Pfizer: investigate the margin and turnover decline together</a:t>
+              <a:t>Across the same 40 firms, margin contributes most to the 2025 rebound</a:t>
             </a:r>
           </a:p>
         </p:txBody>
       </p:sp>
       <p:pic>
         <p:nvPicPr>
-          <p:cNvPr id="3" name="Picture 2" descr="pfizer_bridge.png"/>
+          <p:cNvPr id="3" name="Picture 2" descr="all_year_contributions.png"/>
           <p:cNvPicPr>
             <a:picLocks noChangeAspect="1"/>
           </p:cNvPicPr>
@@ -5160,7 +5155,7 @@
               </a:defRPr>
             </a:pPr>
             <a:r>
-              <a:t>Filing: reduced COVID-product demand and significant inventory write-offs.</a:t>
+              <a:t>2025 mean ROE change: +3.85 pp.</a:t>
             </a:r>
           </a:p>
           <a:p>
@@ -5175,7 +5170,7 @@
               </a:defRPr>
             </a:pPr>
             <a:r>
-              <a:t>Mechanism: demand/inventory pressure can affect earnings and assets.</a:t>
+              <a:t>Margin: +4.34 pp</a:t>
             </a:r>
           </a:p>
           <a:p>
@@ -5190,7 +5185,37 @@
               </a:defRPr>
             </a:pPr>
             <a:r>
-              <a:t>This bridge is accounting attribution, not a causal estimate.</a:t>
+              <a:t>Turnover: +0.65 pp</a:t>
+            </a:r>
+          </a:p>
+          <a:p>
+            <a:pPr>
+              <a:spcAft>
+                <a:spcPts val="1200"/>
+              </a:spcAft>
+              <a:defRPr sz="2000">
+                <a:solidFill>
+                  <a:srgbClr val="25364A"/>
+                </a:solidFill>
+              </a:defRPr>
+            </a:pPr>
+            <a:r>
+              <a:t>Multiplier: −1.14 pp</a:t>
+            </a:r>
+          </a:p>
+          <a:p>
+            <a:pPr>
+              <a:spcAft>
+                <a:spcPts val="1200"/>
+              </a:spcAft>
+              <a:defRPr sz="2000">
+                <a:solidFill>
+                  <a:srgbClr val="25364A"/>
+                </a:solidFill>
+              </a:defRPr>
+            </a:pPr>
+            <a:r>
+              <a:t>These are accounting contributions, not causal effects.</a:t>
             </a:r>
           </a:p>
         </p:txBody>
@@ -5228,7 +5253,7 @@
               </a:defRPr>
             </a:pPr>
             <a:r>
-              <a:t>Source: Pfizer 2023 10-K + matched financial quantities • Exact contribution values supplied in CSV/JSON</a:t>
+              <a:t>Five annual transitions • 200 firm-level bridges • Exact additive accounting attribution</a:t>
             </a:r>
           </a:p>
         </p:txBody>

</xml_diff>

<commit_message>
Frame presentation around ROE research questions and evidence-backed answers
</commit_message>
<xml_diff>
--- a/presentations/homework5_team/Homework5_Team_10_Slides.pptx
+++ b/presentations/homework5_team/Homework5_Team_10_Slides.pptx
@@ -511,7 +511,7 @@
           <a:lstStyle/>
           <a:p>
             <a:r>
-              <a:t>Introduce both team members. Explain that the briefing distinguishes observed ratios, management disclosures and proposed actions. It is not a buy/sell recommendation. The industrial numerical panel has not passed the same checks as healthcare; do not imply a fully validated cross-sector test.</a:t>
+              <a:t>Road map: what happened; accounting explanations; business evidence; monitoring implications. The quantitative findings concern the eligible healthcare sample. The industrial portion is a verified 3M disclosure case, not a validated sector-wide statistical comparison. Sustainability is a question to investigate, not an estimated probability.</a:t>
             </a:r>
           </a:p>
         </p:txBody>
@@ -581,7 +581,7 @@
           <a:lstStyle/>
           <a:p>
             <a:r>
-              <a:t>Suggested owners: CFO/finance for the accounting bridge; supply-chain leaders for operational indicators; analytics/risk team for disclosure coding. This is an ERM monitoring recommendation, not a tested claim of cost savings or a security valuation. Important assignment limitations: validated sector-wide risk frequency/severity and comparable industrial four-component annual medians are not yet complete. The 10-slide cap includes this slide; do not append a second full deck. Both presenters should acknowledge scope openly in Q&amp;A.</a:t>
+              <a:t>Close by answering the research question directly. Recommended monitoring owners: finance for recurring earnings, transaction charges and equity rollforwards; operations for inventory aging, write-offs, delivery and supplier concentration; risk analytics for reviewed disclosure coding. These operating KPIs are recommendations, not measurements already present in our dataset. The evidence supports accounting explanations and selected documented cases, not a causal model or sustainability forecast. Remaining Homework 5 gaps: completed reviewed all-years AI comparison, validated sector-wide risk frequency/severity, and comparable industrial four-component annual statistics. This ten-slide deck remains an evidence-limited team briefing.</a:t>
             </a:r>
           </a:p>
         </p:txBody>
@@ -651,7 +651,7 @@
           <a:lstStyle/>
           <a:p>
             <a:r>
-              <a:t>Use the year-end-balance dataset only. 318 matched company-years exist across 56 firms; 49 have five matched years, 47 have six, and 43 have five unflagged equity years. The main 2025 cross-section has 41 observations. Source: recovered homework_basis/financials.csv. Industry-wide four-component comparison remains incomplete without the industrial raw input table. Changes in medians are not medians of within-firm changes.</a:t>
+              <a:t>Margin = net income/revenue; turnover = revenue/assets; multiplier = assets/equity. Dollars cancel; ROE and margin are dimensionless ratios expressed as percentages. Example .20 × .50 × 2 = .20 = 20%. Book equity is assets minus liabilities, not market capitalization. Year-end denominators are used consistently here; do not mix with older average-balance graphs. Agilent lacks matched 2020, Bio-Techne lacks matched 2025, AbbVie has negative 2025 equity of $3.27bn. Missing matched data does not prove missing SEC filing. Professor benchmark is 45; verified eligible count here is 43. Inclusion requires five usable years, fixed panel six. 2026 filing dates can describe fiscal 2025.</a:t>
             </a:r>
           </a:p>
         </p:txBody>
@@ -721,7 +721,7 @@
           <a:lstStyle/>
           <a:p>
             <a:r>
-              <a:t>255 eligible company-years; 43 distinct firms. Missing or flagged years are not imputed. Scatter x = net income / year-end assets; y = net income / year-end equity. Their ratio is the equity multiplier. This is a mechanical relationship, not an independent causal test. A company appears in multiple panels: observations are dependent. Full ticker-by-year values are in roe_all_years_percent.csv and all_company_years.png. The previous Amgen/IDEXX pair was illustrative, not the entire analyzed sample.</a:t>
+              <a:t>These are separately calculated annual medians for a balanced 40-company sample. Their product does not equal median ROE. Fixing membership removes changing-composition effects within this panel, not survivorship or selection bias. Median ROE changes describe distributions, not a typical company causal effect. Data: balanced_component_medians.csv. Companies have different fiscal year-end dates.</a:t>
             </a:r>
           </a:p>
         </p:txBody>
@@ -791,7 +791,7 @@
           <a:lstStyle/>
           <a:p>
             <a:r>
-              <a:t>For each firm and consecutive year, replace margin, turnover and multiplier in all six possible orders; average each factor’s incremental contribution. Then average firm contributions equally across the same 40 companies. Contributions sum exactly to the change in mean ROE. This is NOT a decomposition of median ROE. The 2021 increase is predominantly margin; all three components contribute negatively in 2023. Firm-level contributions and aggregate means are supplied as CSV. To investigate causes, use company disclosures: Pfizer 2023 discusses lower COVID demand, inventory write-offs and Seagen acquisition, but this does not establish the sector-wide causal effect. Source: https://www.sec.gov/Archives/edgar/data/78003/000007800324000039/0000078003-24-000039.txt</a:t>
+              <a:t>Each dot represents a firm in the indicated year; repeated dots across years are not independent observations. x = net income/assets, y = net income/equity; y = x × equity multiplier. Amgen margin .209817 × turnover .405703 × multiplier 10.462693 = ROE .890621. IDEXX .246175 × 1.284396 × 2.087202 = .659945. Asset returns are about 8.51% and 31.62%, respectively. This demonstrates the accounting denominator effect, not the historical cause of equity levels. Buybacks, losses, distributions and acquisitions require separate evidence. Names of annual top-ten firms are supplied in top10_each_year.csv; the full eligible table has 255 rows.</a:t>
             </a:r>
           </a:p>
         </p:txBody>
@@ -861,12 +861,7 @@
           <a:lstStyle/>
           <a:p>
             <a:r>
-              <a:t>Industrial source independently read: 3M 2024 10-K, https://www.sec.gov/Archives/edgar/data/66740/000006674025000006/0000066740-25-000006.txt</a:t>
-            </a:r>
-          </a:p>
-          <a:p>
-            <a:r>
-              <a:t>Exact excerpts: “some of our suppliers are limited- or sole-source suppliers”; “In 2024, global supply chains stabilized, with disruptions driven from more isolated factors”; “Market price risks were partially mitigated via negotiated supply contracts and leveraging scale across supply base.” This juxtaposition is useful: risk factors are exposures, while business/MD&amp;A discusses realized conditions. Do not attribute 3M ROE movements to supplier risks without reconciling settlement, tax, spin-off and earnings effects. The filing reports PFAS liabilities retained in connection with the Solventum separation.</a:t>
+              <a:t>For each of 40 firms, decompose each adjacent-year ROE change by averaging contributions over all six orders of replacing margin, turnover and multiplier. Average each contribution across firms. The three contributions sum to the change in mean ROE, not median ROE. 200 firm-level bridges. A one-percentage-point change means, for example, 10% to 11%. 2021 mean increase is 6.098 pp, of which margin contributes 6.235 pp. In 2023 all three average contributions are negative. Accounting allocations do not estimate counterfactual event effects.</a:t>
             </a:r>
           </a:p>
         </p:txBody>
@@ -936,7 +931,7 @@
           <a:lstStyle/>
           <a:p>
             <a:r>
-              <a:t>Computed from the partner-provided industrials_analysis.jsonl: all 472 records have risk_score_1_to_10 equal to 5. This is a frequency of model outputs, not a frequency or severity of economic risks. Constant values have zero variance, so correlation with ROE is undefined. The supplied industrial prompt contains an example risk score of 5; this may warrant investigating anchoring, but we have not established why all outputs match it. Required sector-wide market/operational/regulatory/financial risk frequency and severity analysis remains incomplete. Do not present these scores as validated measurements.</a:t>
+              <a:t>Company averages use each eligible firm’s five or six unflagged years, then equal company weights. Sample SD is 21.90 percentage points. IQR = Q3−Q1; flag values below Q1−1.5IQR or above Q3+1.5IQR. ROE-only flags: ABBV, AMGN, IDXX, LLY, ZTS. Removing five leaves 38 firms with mean 13.50%. Alternative mean ±2 sample SD removes four, leaving 39 and mean 14.50%. Neither rule proves an accounting error. No normal bell-curve assumption, random sample inference or causal significance claim. Extreme group selection and repeated observations also constrain the risk comparison.</a:t>
             </a:r>
           </a:p>
         </p:txBody>
@@ -1006,7 +1001,7 @@
           <a:lstStyle/>
           <a:p>
             <a:r>
-              <a:t>These arrows describe plausible mechanisms and proposed monitoring, not causal coefficients estimated in our study. Inventory days, delivery performance and forecast errors are not measured in the current financial dataset. Distinguish a write-off effect on earnings/assets from a sales-volume effect on turnover. Healthcare evidence: Pfizer 2023. Industrial evidence: 3M 2024. Risk-category labels: market demand and operational inventory for Pfizer; operational sourcing and market input prices for 3M.</a:t>
+              <a:t>Pfizer year-end ROE fell from 32.795% in 2022 to 2.381% in 2023. Symmetric contributions: margin −24.350 pp, turnover −9.585 pp, multiplier +3.520 pp. Source: https://www.sec.gov/Archives/edgar/data/78003/000007800324000039/0000078003-24-000039.txt. The filing discusses reduced COVID-product demand, excess inventory and significant Paxlovid/Comirnaty write-offs. Seagen is an additional asset-base issue. This is one verified case, not a sector explanation. Management expected at least $4bn cost realignment net savings primarily in 2023–2024; we have not verified realized savings. Proposed follow-up: revenue mix, inventory charges, acquisition effects and realized savings.</a:t>
             </a:r>
           </a:p>
         </p:txBody>
@@ -1076,22 +1071,7 @@
           <a:lstStyle/>
           <a:p>
             <a:r>
-              <a:t>Pfizer source: https://www.sec.gov/Archives/edgar/data/78003/000007800324000039/0000078003-24-000039.txt</a:t>
-            </a:r>
-          </a:p>
-          <a:p>
-            <a:r>
-              <a:t>Exact wording includes “This program is expected to deliver net cost savings of at least $4 billion, to be achieved primarily from 2023 through 2024.” This was a forward-looking statement in that filing; we have not verified realized savings.</a:t>
-            </a:r>
-          </a:p>
-          <a:p>
-            <a:r>
-              <a:t>3M source: https://www.sec.gov/Archives/edgar/data/66740/000006674025000006/0000066740-25-000006.txt</a:t>
-            </a:r>
-          </a:p>
-          <a:p>
-            <a:r>
-              <a:t>Reported partial mitigation is management’s account, not our independent causal estimate. Suggested monitoring is the team recommendation, separate from reported actions.</a:t>
+              <a:t>Source: 3M 2024 10-K https://www.sec.gov/Archives/edgar/data/66740/000006674025000006/0000066740-25-000006.txt. Exact excerpts include “some of our suppliers are limited- or sole-source suppliers”; “In 2024, global supply chains stabilized, with disruptions driven from more isolated factors”; “Market price risks were partially mitigated via negotiated supply contracts and leveraging scale across supply base.” This illustrates how Item 1A exposures differ from realized conditions discussed elsewhere. The filing does not support attributing all ROE changes to sourcing. Comparable industrial four-component quantitative panel remains unverified. Industrial files have not been edited.</a:t>
             </a:r>
           </a:p>
         </p:txBody>
@@ -1161,7 +1141,7 @@
           <a:lstStyle/>
           <a:p>
             <a:r>
-              <a:t>43 eligible company-average ROEs: mean 20.74%, sample SD 21.90 percentage points. IQR-only ROE outliers: ABBV, AMGN, IDXX, LLY and ZTS. Removing them leaves 38 firms and mean 13.50%. Two-SD ROE flags exclude four firms, leaving 39 and mean 14.50%. These are not 2025-only statistics. Repeated firm-years are dependent; ratios share components; the selected sample is not random. No normality assumption or causal significance claim. Source spreadsheet: outlier_mean_sensitivity.csv.</a:t>
+              <a:t>Do not present a high-versus-low risk difference as a finding yet. Ten selected disclosure matches are missing: ZBH 2020/2021/2022/2023/2025, STE 2021/2022/2023/2024, CI 2021. Financial rankings retain all 120 entries. The 110 matched filings represent 33 companies and 549 chunks, not 549 independent observations. Rank groups change annually. Later financial history is retrospective context. Exact quote and URL validation does not validate causal interpretations. Partner industrial scores are all 5 across 472 records, with no anchored rubric; constant scores cannot support correlation. Required sector-wide risk-frequency/severity measurement remains incomplete.</a:t>
             </a:r>
           </a:p>
         </p:txBody>
@@ -4191,7 +4171,7 @@
           <a:p>
             <a:pPr>
               <a:spcAft>
-                <a:spcPts val="1200"/>
+                <a:spcPts val="800"/>
               </a:spcAft>
               <a:defRPr sz="2900">
                 <a:solidFill>
@@ -4200,7 +4180,7 @@
               </a:defRPr>
             </a:pPr>
             <a:r>
-              <a:t>Healthcare + industrials: what should an ERM team monitor?</a:t>
+              <a:t>What is behind healthcare ROE—and how sustainable is it?</a:t>
             </a:r>
           </a:p>
         </p:txBody>
@@ -4229,61 +4209,46 @@
           <a:p>
             <a:pPr>
               <a:spcAft>
-                <a:spcPts val="1200"/>
+                <a:spcPts val="800"/>
               </a:spcAft>
-              <a:defRPr sz="2300">
+              <a:defRPr sz="2100">
                 <a:solidFill>
                   <a:srgbClr val="25364A"/>
                 </a:solidFill>
               </a:defRPr>
             </a:pPr>
             <a:r>
-              <a:t>Stakeholder: Enterprise Risk Management consultant.</a:t>
+              <a:t>Research question: Why do healthcare companies differ in ROE, how did those differences change during 2020–2025, and what do disclosed risks suggest about sustainability?</a:t>
             </a:r>
           </a:p>
           <a:p>
             <a:pPr>
               <a:spcAft>
-                <a:spcPts val="1200"/>
+                <a:spcPts val="800"/>
               </a:spcAft>
-              <a:defRPr sz="2300">
+              <a:defRPr sz="2100">
                 <a:solidFill>
                   <a:srgbClr val="25364A"/>
                 </a:solidFill>
               </a:defRPr>
             </a:pPr>
             <a:r>
-              <a:t>Question: Which financial patterns warrant a closer review of disclosed operating risks?</a:t>
+              <a:t>Our finding: returns vary widely; margins and the equity base both matter. High ROE alone does not establish strong, sustainable performance.</a:t>
             </a:r>
           </a:p>
           <a:p>
             <a:pPr>
               <a:spcAft>
-                <a:spcPts val="1200"/>
+                <a:spcPts val="800"/>
               </a:spcAft>
-              <a:defRPr sz="2300">
+              <a:defRPr sz="2100">
                 <a:solidFill>
                   <a:srgbClr val="25364A"/>
                 </a:solidFill>
               </a:defRPr>
             </a:pPr>
             <a:r>
-              <a:t>Recommendation: investigate the earnings, asset and equity mechanisms before ranking companies by ROE.</a:t>
-            </a:r>
-          </a:p>
-          <a:p>
-            <a:pPr>
-              <a:spcAft>
-                <a:spcPts val="1200"/>
-              </a:spcAft>
-              <a:defRPr sz="2300">
-                <a:solidFill>
-                  <a:srgbClr val="25364A"/>
-                </a:solidFill>
-              </a:defRPr>
-            </a:pPr>
-            <a:r>
-              <a:t>Scope: fiscal 2020–2025; quantitative healthcare study plus an industrial disclosure case.</a:t>
+              <a:t>Audience: enterprise risk management. Industrial evidence provides a comparison case.</a:t>
             </a:r>
           </a:p>
         </p:txBody>
@@ -4312,7 +4277,7 @@
           <a:p>
             <a:pPr>
               <a:spcAft>
-                <a:spcPts val="1200"/>
+                <a:spcPts val="800"/>
               </a:spcAft>
               <a:defRPr sz="1100">
                 <a:solidFill>
@@ -4321,7 +4286,7 @@
               </a:defRPr>
             </a:pPr>
             <a:r>
-              <a:t>Homework 5 • 10-slide team working briefing • Sources and defense notes are in speaker notes</a:t>
+              <a:t>Homework 5 • Question-led team briefing • Fiscal 2020–2025 • 10 slides</a:t>
             </a:r>
           </a:p>
         </p:txBody>
@@ -4350,7 +4315,7 @@
           <a:p>
             <a:pPr>
               <a:spcAft>
-                <a:spcPts val="1200"/>
+                <a:spcPts val="800"/>
               </a:spcAft>
               <a:defRPr sz="1100">
                 <a:solidFill>
@@ -4406,7 +4371,7 @@
           <a:p>
             <a:pPr>
               <a:spcAft>
-                <a:spcPts val="1200"/>
+                <a:spcPts val="800"/>
               </a:spcAft>
               <a:defRPr sz="2900">
                 <a:solidFill>
@@ -4415,7 +4380,7 @@
               </a:defRPr>
             </a:pPr>
             <a:r>
-              <a:t>ERM recommendation: prioritize evidence-backed monitoring</a:t>
+              <a:t>Why care? High ROE is a signal to investigate its source</a:t>
             </a:r>
           </a:p>
         </p:txBody>
@@ -4444,76 +4409,76 @@
           <a:p>
             <a:pPr>
               <a:spcAft>
-                <a:spcPts val="1200"/>
+                <a:spcPts val="800"/>
               </a:spcAft>
-              <a:defRPr sz="2300">
+              <a:defRPr sz="2100">
                 <a:solidFill>
                   <a:srgbClr val="25364A"/>
                 </a:solidFill>
               </a:defRPr>
             </a:pPr>
             <a:r>
-              <a:t>Finance: separate recurring earnings, transaction charges and equity-denominator effects in the ROE review.</a:t>
+              <a:t>WHAT HAPPENED: sample median ROE fell after 2021 and partly recovered in 2025.</a:t>
             </a:r>
           </a:p>
           <a:p>
             <a:pPr>
               <a:spcAft>
-                <a:spcPts val="1200"/>
+                <a:spcPts val="800"/>
               </a:spcAft>
-              <a:defRPr sz="2300">
+              <a:defRPr sz="2100">
                 <a:solidFill>
                   <a:srgbClr val="25364A"/>
                 </a:solidFill>
               </a:defRPr>
             </a:pPr>
             <a:r>
-              <a:t>Operations: track demand/inventory exposure in healthcare and critical supplier/cost exposure in industrials.</a:t>
+              <a:t>WHAT ACCOUNTS FOR IT: margins matter; a small equity base can magnify returns.</a:t>
             </a:r>
           </a:p>
           <a:p>
             <a:pPr>
               <a:spcAft>
-                <a:spcPts val="1200"/>
+                <a:spcPts val="800"/>
               </a:spcAft>
-              <a:defRPr sz="2300">
+              <a:defRPr sz="2100">
                 <a:solidFill>
                   <a:srgbClr val="25364A"/>
                 </a:solidFill>
               </a:defRPr>
             </a:pPr>
             <a:r>
-              <a:t>Analytics: validate risk categories and severity with a written rubric and independent human checks.</a:t>
+              <a:t>WHAT RISKS ADD: filings identify exposures and business context, but do not prove causality.</a:t>
             </a:r>
           </a:p>
           <a:p>
             <a:pPr>
               <a:spcAft>
-                <a:spcPts val="1200"/>
+                <a:spcPts val="800"/>
               </a:spcAft>
-              <a:defRPr sz="2300">
+              <a:defRPr sz="2100">
                 <a:solidFill>
                   <a:srgbClr val="25364A"/>
                 </a:solidFill>
               </a:defRPr>
             </a:pPr>
             <a:r>
-              <a:t>Before sector-wide rankings: reconcile industrial raw financial inputs and apply comparable screening.</a:t>
+              <a:t>ACTION: finance should review equity and one-time charges; operations should track demand, inventory and supplier performance.</a:t>
             </a:r>
           </a:p>
           <a:p>
             <a:pPr>
               <a:spcAft>
-                <a:spcPts val="1200"/>
+                <a:spcPts val="800"/>
               </a:spcAft>
-              <a:defRPr sz="2300">
+              <a:defRPr sz="2100">
                 <a:solidFill>
                   <a:srgbClr val="25364A"/>
                 </a:solidFill>
               </a:defRPr>
             </a:pPr>
             <a:r>
-              <a:t>Takeaway: use ROE to locate questions; use disclosures and operating evidence to guide action.</a:t>
+              <a:t>SUSTAINABILITY: cannot be concluded from ROE alone; test recurring earnings and realized mitigation outcomes.</a:t>
             </a:r>
           </a:p>
         </p:txBody>
@@ -4542,7 +4507,7 @@
           <a:p>
             <a:pPr>
               <a:spcAft>
-                <a:spcPts val="1200"/>
+                <a:spcPts val="800"/>
               </a:spcAft>
               <a:defRPr sz="1100">
                 <a:solidFill>
@@ -4551,7 +4516,7 @@
               </a:defRPr>
             </a:pPr>
             <a:r>
-              <a:t>Executive recommendation • Evidence-limited team draft; missing assignment components are disclosed</a:t>
+              <a:t>Q4: Management implications • Recommendations follow observed patterns and verified cases</a:t>
             </a:r>
           </a:p>
         </p:txBody>
@@ -4580,7 +4545,7 @@
           <a:p>
             <a:pPr>
               <a:spcAft>
-                <a:spcPts val="1200"/>
+                <a:spcPts val="800"/>
               </a:spcAft>
               <a:defRPr sz="1100">
                 <a:solidFill>
@@ -4636,7 +4601,7 @@
           <a:p>
             <a:pPr>
               <a:spcAft>
-                <a:spcPts val="1200"/>
+                <a:spcPts val="800"/>
               </a:spcAft>
               <a:defRPr sz="2900">
                 <a:solidFill>
@@ -4645,45 +4610,21 @@
               </a:defRPr>
             </a:pPr>
             <a:r>
-              <a:t>Healthcare trends persist when membership is held constant</a:t>
-            </a:r>
-          </a:p>
-        </p:txBody>
-      </p:sp>
-      <p:pic>
-        <p:nvPicPr>
-          <p:cNvPr id="3" name="Picture 2" descr="four_components_all_years.png"/>
-          <p:cNvPicPr>
-            <a:picLocks noChangeAspect="1"/>
-          </p:cNvPicPr>
-          <p:nvPr/>
-        </p:nvPicPr>
-        <p:blipFill>
-          <a:blip r:embed="rId2"/>
-          <a:stretch>
-            <a:fillRect/>
-          </a:stretch>
-        </p:blipFill>
-        <p:spPr>
-          <a:xfrm>
-            <a:off x="378822" y="1234440"/>
-            <a:ext cx="7471954" cy="4754880"/>
-          </a:xfrm>
-          <a:prstGeom prst="rect">
-            <a:avLst/>
-          </a:prstGeom>
-        </p:spPr>
-      </p:pic>
-      <p:sp>
-        <p:nvSpPr>
-          <p:cNvPr id="4" name="TextBox 3"/>
+              <a:t>ROE measures profit per dollar of book equity</a:t>
+            </a:r>
+          </a:p>
+        </p:txBody>
+      </p:sp>
+      <p:sp>
+        <p:nvSpPr>
+          <p:cNvPr id="3" name="TextBox 2"/>
           <p:cNvSpPr txBox="1"/>
           <p:nvPr/>
         </p:nvSpPr>
         <p:spPr>
           <a:xfrm>
-            <a:off x="8046720" y="1463040"/>
-            <a:ext cx="3566160" cy="4480560"/>
+            <a:off x="731520" y="1417320"/>
+            <a:ext cx="10698480" cy="4526280"/>
           </a:xfrm>
           <a:prstGeom prst="rect">
             <a:avLst/>
@@ -4698,53 +4639,83 @@
           <a:p>
             <a:pPr>
               <a:spcAft>
-                <a:spcPts val="1200"/>
+                <a:spcPts val="800"/>
               </a:spcAft>
-              <a:defRPr sz="2000">
+              <a:defRPr sz="2100">
                 <a:solidFill>
                   <a:srgbClr val="25364A"/>
                 </a:solidFill>
               </a:defRPr>
             </a:pPr>
             <a:r>
-              <a:t>43 eligible firms; 40 have all six years.</a:t>
+              <a:t>ROE = net income ÷ year-end shareholders’ equity × 100.</a:t>
             </a:r>
           </a:p>
           <a:p>
             <a:pPr>
               <a:spcAft>
-                <a:spcPts val="1200"/>
+                <a:spcPts val="800"/>
               </a:spcAft>
-              <a:defRPr sz="2000">
+              <a:defRPr sz="2100">
                 <a:solidFill>
                   <a:srgbClr val="25364A"/>
                 </a:solidFill>
               </a:defRPr>
             </a:pPr>
             <a:r>
-              <a:t>The fixed-company line reduces changing-membership effects.</a:t>
+              <a:t>20% ROE means $0.20 annual profit per $1 of book equity. It is not a stock-market return.</a:t>
             </a:r>
           </a:p>
           <a:p>
             <a:pPr>
               <a:spcAft>
-                <a:spcPts val="1200"/>
+                <a:spcPts val="800"/>
               </a:spcAft>
-              <a:defRPr sz="2000">
+              <a:defRPr sz="2100">
                 <a:solidFill>
                   <a:srgbClr val="25364A"/>
                 </a:solidFill>
               </a:defRPr>
             </a:pPr>
             <a:r>
-              <a:t>It does not remove survivorship or accounting-selection bias.</a:t>
-            </a:r>
-          </a:p>
-        </p:txBody>
-      </p:sp>
-      <p:sp>
-        <p:nvSpPr>
-          <p:cNvPr id="5" name="TextBox 4"/>
+              <a:t>DuPont: profit margin × asset turnover × equity multiplier = ROE.</a:t>
+            </a:r>
+          </a:p>
+          <a:p>
+            <a:pPr>
+              <a:spcAft>
+                <a:spcPts val="800"/>
+              </a:spcAft>
+              <a:defRPr sz="2100">
+                <a:solidFill>
+                  <a:srgbClr val="25364A"/>
+                </a:solidFill>
+              </a:defRPr>
+            </a:pPr>
+            <a:r>
+              <a:t>Coverage: 43 eligible firms / 255 company-years; 40 firms have all six usable years.</a:t>
+            </a:r>
+          </a:p>
+          <a:p>
+            <a:pPr>
+              <a:spcAft>
+                <a:spcPts val="800"/>
+              </a:spcAft>
+              <a:defRPr sz="2100">
+                <a:solidFill>
+                  <a:srgbClr val="25364A"/>
+                </a:solidFill>
+              </a:defRPr>
+            </a:pPr>
+            <a:r>
+              <a:t>A, ABBV and TECH retain five usable years each; they are outside the fixed 40-firm panel.</a:t>
+            </a:r>
+          </a:p>
+        </p:txBody>
+      </p:sp>
+      <p:sp>
+        <p:nvSpPr>
+          <p:cNvPr id="4" name="TextBox 3"/>
           <p:cNvSpPr txBox="1"/>
           <p:nvPr/>
         </p:nvSpPr>
@@ -4766,7 +4737,7 @@
           <a:p>
             <a:pPr>
               <a:spcAft>
-                <a:spcPts val="1200"/>
+                <a:spcPts val="800"/>
               </a:spcAft>
               <a:defRPr sz="1100">
                 <a:solidFill>
@@ -4775,14 +4746,14 @@
               </a:defRPr>
             </a:pPr>
             <a:r>
-              <a:t>Source: recovered SEC financial panel • Year-end balances • Industrial four-component medians not yet verified</a:t>
-            </a:r>
-          </a:p>
-        </p:txBody>
-      </p:sp>
-      <p:sp>
-        <p:nvSpPr>
-          <p:cNvPr id="6" name="TextBox 5"/>
+              <a:t>Source: SEC-derived financial panel • Year-end denominators • Selection and equity exclusions limit generalization</a:t>
+            </a:r>
+          </a:p>
+        </p:txBody>
+      </p:sp>
+      <p:sp>
+        <p:nvSpPr>
+          <p:cNvPr id="5" name="TextBox 4"/>
           <p:cNvSpPr txBox="1"/>
           <p:nvPr/>
         </p:nvSpPr>
@@ -4804,7 +4775,7 @@
           <a:p>
             <a:pPr>
               <a:spcAft>
-                <a:spcPts val="1200"/>
+                <a:spcPts val="800"/>
               </a:spcAft>
               <a:defRPr sz="1100">
                 <a:solidFill>
@@ -4860,7 +4831,7 @@
           <a:p>
             <a:pPr>
               <a:spcAft>
-                <a:spcPts val="1200"/>
+                <a:spcPts val="800"/>
               </a:spcAft>
               <a:defRPr sz="2900">
                 <a:solidFill>
@@ -4869,14 +4840,14 @@
               </a:defRPr>
             </a:pPr>
             <a:r>
-              <a:t>Look across every year before selecting individual examples</a:t>
+              <a:t>What happened? Median ROE peaked in 2021, then fell</a:t>
             </a:r>
           </a:p>
         </p:txBody>
       </p:sp>
       <p:pic>
         <p:nvPicPr>
-          <p:cNvPr id="3" name="Picture 2" descr="all_year_scatter.png"/>
+          <p:cNvPr id="3" name="Picture 2" descr="four_components_all_years.png"/>
           <p:cNvPicPr>
             <a:picLocks noChangeAspect="1"/>
           </p:cNvPicPr>
@@ -4890,8 +4861,8 @@
         </p:blipFill>
         <p:spPr>
           <a:xfrm>
-            <a:off x="365760" y="1234440"/>
-            <a:ext cx="7498079" cy="4373880"/>
+            <a:off x="378822" y="1234440"/>
+            <a:ext cx="7471954" cy="4754880"/>
           </a:xfrm>
           <a:prstGeom prst="rect">
             <a:avLst/>
@@ -4922,7 +4893,7 @@
           <a:p>
             <a:pPr>
               <a:spcAft>
-                <a:spcPts val="1200"/>
+                <a:spcPts val="800"/>
               </a:spcAft>
               <a:defRPr sz="2000">
                 <a:solidFill>
@@ -4931,13 +4902,13 @@
               </a:defRPr>
             </a:pPr>
             <a:r>
-              <a:t>All 43 eligible companies contribute available observations.</a:t>
+              <a:t>Same 40 firms each year.</a:t>
             </a:r>
           </a:p>
           <a:p>
             <a:pPr>
               <a:spcAft>
-                <a:spcPts val="1200"/>
+                <a:spcPts val="800"/>
               </a:spcAft>
               <a:defRPr sz="2000">
                 <a:solidFill>
@@ -4946,13 +4917,13 @@
               </a:defRPr>
             </a:pPr>
             <a:r>
-              <a:t>Each dot is one company in that year.</a:t>
+              <a:t>Median ROE: 18.68% in 2021 → 11.13% in 2024 → 12.68% in 2025.</a:t>
             </a:r>
           </a:p>
           <a:p>
             <a:pPr>
               <a:spcAft>
-                <a:spcPts val="1200"/>
+                <a:spcPts val="800"/>
               </a:spcAft>
               <a:defRPr sz="2000">
                 <a:solidFill>
@@ -4961,7 +4932,7 @@
               </a:defRPr>
             </a:pPr>
             <a:r>
-              <a:t>A high ROE can reflect a small equity base, not just strong asset returns.</a:t>
+              <a:t>2025 recovered partly, but stayed below the 2021 peak.</a:t>
             </a:r>
           </a:p>
         </p:txBody>
@@ -4990,7 +4961,7 @@
           <a:p>
             <a:pPr>
               <a:spcAft>
-                <a:spcPts val="1200"/>
+                <a:spcPts val="800"/>
               </a:spcAft>
               <a:defRPr sz="1100">
                 <a:solidFill>
@@ -4999,7 +4970,7 @@
               </a:defRPr>
             </a:pPr>
             <a:r>
-              <a:t>All available eligible firm-years • Same year-end accounting basis • No outliers hidden</a:t>
+              <a:t>Q1: What happened? • Fixed-company descriptive trends • Separate component medians are not additive</a:t>
             </a:r>
           </a:p>
         </p:txBody>
@@ -5028,7 +4999,7 @@
           <a:p>
             <a:pPr>
               <a:spcAft>
-                <a:spcPts val="1200"/>
+                <a:spcPts val="800"/>
               </a:spcAft>
               <a:defRPr sz="1100">
                 <a:solidFill>
@@ -5084,7 +5055,7 @@
           <a:p>
             <a:pPr>
               <a:spcAft>
-                <a:spcPts val="1200"/>
+                <a:spcPts val="800"/>
               </a:spcAft>
               <a:defRPr sz="2900">
                 <a:solidFill>
@@ -5093,14 +5064,14 @@
               </a:defRPr>
             </a:pPr>
             <a:r>
-              <a:t>Across the same 40 firms, margin contributes most to the 2025 rebound</a:t>
+              <a:t>Why do returns differ? The equity base can amplify ROE</a:t>
             </a:r>
           </a:p>
         </p:txBody>
       </p:sp>
       <p:pic>
         <p:nvPicPr>
-          <p:cNvPr id="3" name="Picture 2" descr="all_year_contributions.png"/>
+          <p:cNvPr id="3" name="Picture 2" descr="all_year_scatter.png"/>
           <p:cNvPicPr>
             <a:picLocks noChangeAspect="1"/>
           </p:cNvPicPr>
@@ -5115,7 +5086,7 @@
         <p:spPr>
           <a:xfrm>
             <a:off x="365760" y="1234440"/>
-            <a:ext cx="7498079" cy="3749039"/>
+            <a:ext cx="7498079" cy="4373880"/>
           </a:xfrm>
           <a:prstGeom prst="rect">
             <a:avLst/>
@@ -5146,7 +5117,7 @@
           <a:p>
             <a:pPr>
               <a:spcAft>
-                <a:spcPts val="1200"/>
+                <a:spcPts val="800"/>
               </a:spcAft>
               <a:defRPr sz="2000">
                 <a:solidFill>
@@ -5155,13 +5126,13 @@
               </a:defRPr>
             </a:pPr>
             <a:r>
-              <a:t>2025 mean ROE change: +3.85 pp.</a:t>
+              <a:t>Every eligible company-year is plotted.</a:t>
             </a:r>
           </a:p>
           <a:p>
             <a:pPr>
               <a:spcAft>
-                <a:spcPts val="1200"/>
+                <a:spcPts val="800"/>
               </a:spcAft>
               <a:defRPr sz="2000">
                 <a:solidFill>
@@ -5170,13 +5141,13 @@
               </a:defRPr>
             </a:pPr>
             <a:r>
-              <a:t>Margin: +4.34 pp</a:t>
+              <a:t>2025 Amgen: 89.06% ROE; multiplier 10.46×.</a:t>
             </a:r>
           </a:p>
           <a:p>
             <a:pPr>
               <a:spcAft>
-                <a:spcPts val="1200"/>
+                <a:spcPts val="800"/>
               </a:spcAft>
               <a:defRPr sz="2000">
                 <a:solidFill>
@@ -5185,13 +5156,13 @@
               </a:defRPr>
             </a:pPr>
             <a:r>
-              <a:t>Turnover: +0.65 pp</a:t>
+              <a:t>2025 IDEXX: 65.99% ROE; multiplier 2.09×.</a:t>
             </a:r>
           </a:p>
           <a:p>
             <a:pPr>
               <a:spcAft>
-                <a:spcPts val="1200"/>
+                <a:spcPts val="800"/>
               </a:spcAft>
               <a:defRPr sz="2000">
                 <a:solidFill>
@@ -5200,22 +5171,7 @@
               </a:defRPr>
             </a:pPr>
             <a:r>
-              <a:t>Multiplier: −1.14 pp</a:t>
-            </a:r>
-          </a:p>
-          <a:p>
-            <a:pPr>
-              <a:spcAft>
-                <a:spcPts val="1200"/>
-              </a:spcAft>
-              <a:defRPr sz="2000">
-                <a:solidFill>
-                  <a:srgbClr val="25364A"/>
-                </a:solidFill>
-              </a:defRPr>
-            </a:pPr>
-            <a:r>
-              <a:t>These are accounting contributions, not causal effects.</a:t>
+              <a:t>IDEXX earns more per dollar of assets despite lower ROE.</a:t>
             </a:r>
           </a:p>
         </p:txBody>
@@ -5244,7 +5200,7 @@
           <a:p>
             <a:pPr>
               <a:spcAft>
-                <a:spcPts val="1200"/>
+                <a:spcPts val="800"/>
               </a:spcAft>
               <a:defRPr sz="1100">
                 <a:solidFill>
@@ -5253,7 +5209,7 @@
               </a:defRPr>
             </a:pPr>
             <a:r>
-              <a:t>Five annual transitions • 200 firm-level bridges • Exact additive accounting attribution</a:t>
+              <a:t>Q2: Accounting explanation • Full sample shown; Amgen and IDEXX are illustrations • No causal regression</a:t>
             </a:r>
           </a:p>
         </p:txBody>
@@ -5282,7 +5238,7 @@
           <a:p>
             <a:pPr>
               <a:spcAft>
-                <a:spcPts val="1200"/>
+                <a:spcPts val="800"/>
               </a:spcAft>
               <a:defRPr sz="1100">
                 <a:solidFill>
@@ -5338,7 +5294,7 @@
           <a:p>
             <a:pPr>
               <a:spcAft>
-                <a:spcPts val="1200"/>
+                <a:spcPts val="800"/>
               </a:spcAft>
               <a:defRPr sz="2900">
                 <a:solidFill>
@@ -5347,21 +5303,45 @@
               </a:defRPr>
             </a:pPr>
             <a:r>
-              <a:t>3M: persistent exposure is not the same as current disruption</a:t>
-            </a:r>
-          </a:p>
-        </p:txBody>
-      </p:sp>
-      <p:sp>
-        <p:nvSpPr>
-          <p:cNvPr id="3" name="TextBox 2"/>
+              <a:t>What changed? Margin contributes most to the 2025 rebound</a:t>
+            </a:r>
+          </a:p>
+        </p:txBody>
+      </p:sp>
+      <p:pic>
+        <p:nvPicPr>
+          <p:cNvPr id="3" name="Picture 2" descr="all_year_contributions.png"/>
+          <p:cNvPicPr>
+            <a:picLocks noChangeAspect="1"/>
+          </p:cNvPicPr>
+          <p:nvPr/>
+        </p:nvPicPr>
+        <p:blipFill>
+          <a:blip r:embed="rId2"/>
+          <a:stretch>
+            <a:fillRect/>
+          </a:stretch>
+        </p:blipFill>
+        <p:spPr>
+          <a:xfrm>
+            <a:off x="365760" y="1234440"/>
+            <a:ext cx="7498079" cy="3749039"/>
+          </a:xfrm>
+          <a:prstGeom prst="rect">
+            <a:avLst/>
+          </a:prstGeom>
+        </p:spPr>
+      </p:pic>
+      <p:sp>
+        <p:nvSpPr>
+          <p:cNvPr id="4" name="TextBox 3"/>
           <p:cNvSpPr txBox="1"/>
           <p:nvPr/>
         </p:nvSpPr>
         <p:spPr>
           <a:xfrm>
-            <a:off x="731520" y="1417320"/>
-            <a:ext cx="10698480" cy="4526280"/>
+            <a:off x="8046720" y="1463040"/>
+            <a:ext cx="3566160" cy="4480560"/>
           </a:xfrm>
           <a:prstGeom prst="rect">
             <a:avLst/>
@@ -5376,68 +5356,68 @@
           <a:p>
             <a:pPr>
               <a:spcAft>
-                <a:spcPts val="1200"/>
+                <a:spcPts val="800"/>
               </a:spcAft>
-              <a:defRPr sz="2300">
+              <a:defRPr sz="2000">
                 <a:solidFill>
                   <a:srgbClr val="25364A"/>
                 </a:solidFill>
               </a:defRPr>
             </a:pPr>
             <a:r>
-              <a:t>Item 1A: reliance on limited- or sole-source suppliers can threaten availability and customer obligations.</a:t>
+              <a:t>Same 40 firms; five annual changes.</a:t>
             </a:r>
           </a:p>
           <a:p>
             <a:pPr>
               <a:spcAft>
-                <a:spcPts val="1200"/>
+                <a:spcPts val="800"/>
               </a:spcAft>
-              <a:defRPr sz="2300">
+              <a:defRPr sz="2000">
                 <a:solidFill>
                   <a:srgbClr val="25364A"/>
                 </a:solidFill>
               </a:defRPr>
             </a:pPr>
             <a:r>
-              <a:t>Business discussion: global supply chains stabilized in 2024, but feedstock and labor inflation remained.</a:t>
+              <a:t>2025 mean ROE change: +3.85 percentage points.</a:t>
             </a:r>
           </a:p>
           <a:p>
             <a:pPr>
               <a:spcAft>
-                <a:spcPts val="1200"/>
+                <a:spcPts val="800"/>
               </a:spcAft>
-              <a:defRPr sz="2300">
+              <a:defRPr sz="2000">
                 <a:solidFill>
                   <a:srgbClr val="25364A"/>
                 </a:solidFill>
               </a:defRPr>
             </a:pPr>
             <a:r>
-              <a:t>Reported response: negotiated supply contracts and purchasing scale partially mitigated market-price risk.</a:t>
+              <a:t>Margin +4.34; turnover +0.65; multiplier −1.14.</a:t>
             </a:r>
           </a:p>
           <a:p>
             <a:pPr>
               <a:spcAft>
-                <a:spcPts val="1200"/>
+                <a:spcPts val="800"/>
               </a:spcAft>
-              <a:defRPr sz="2300">
+              <a:defRPr sz="2000">
                 <a:solidFill>
                   <a:srgbClr val="25364A"/>
                 </a:solidFill>
               </a:defRPr>
             </a:pPr>
             <a:r>
-              <a:t>Decision: monitor concentration, delivery performance and cost pass-through; do not assume every disclosed risk materialized.</a:t>
-            </a:r>
-          </a:p>
-        </p:txBody>
-      </p:sp>
-      <p:sp>
-        <p:nvSpPr>
-          <p:cNvPr id="4" name="TextBox 3"/>
+              <a:t>This explains the arithmetic, not the business causes.</a:t>
+            </a:r>
+          </a:p>
+        </p:txBody>
+      </p:sp>
+      <p:sp>
+        <p:nvSpPr>
+          <p:cNvPr id="5" name="TextBox 4"/>
           <p:cNvSpPr txBox="1"/>
           <p:nvPr/>
         </p:nvSpPr>
@@ -5459,7 +5439,7 @@
           <a:p>
             <a:pPr>
               <a:spcAft>
-                <a:spcPts val="1200"/>
+                <a:spcPts val="800"/>
               </a:spcAft>
               <a:defRPr sz="1100">
                 <a:solidFill>
@@ -5468,14 +5448,14 @@
               </a:defRPr>
             </a:pPr>
             <a:r>
-              <a:t>Source: 3M 2024 10-K • Item 1 / Item 1A • This is a verified case, not sector prevalence</a:t>
-            </a:r>
-          </a:p>
-        </p:txBody>
-      </p:sp>
-      <p:sp>
-        <p:nvSpPr>
-          <p:cNvPr id="5" name="TextBox 4"/>
+              <a:t>Q2: Accounting explanation • Mean contributions; previous trend slide uses medians • Values rounded</a:t>
+            </a:r>
+          </a:p>
+        </p:txBody>
+      </p:sp>
+      <p:sp>
+        <p:nvSpPr>
+          <p:cNvPr id="6" name="TextBox 5"/>
           <p:cNvSpPr txBox="1"/>
           <p:nvPr/>
         </p:nvSpPr>
@@ -5497,7 +5477,7 @@
           <a:p>
             <a:pPr>
               <a:spcAft>
-                <a:spcPts val="1200"/>
+                <a:spcPts val="800"/>
               </a:spcAft>
               <a:defRPr sz="1100">
                 <a:solidFill>
@@ -5553,7 +5533,7 @@
           <a:p>
             <a:pPr>
               <a:spcAft>
-                <a:spcPts val="1200"/>
+                <a:spcPts val="800"/>
               </a:spcAft>
               <a:defRPr sz="2900">
                 <a:solidFill>
@@ -5562,14 +5542,14 @@
               </a:defRPr>
             </a:pPr>
             <a:r>
-              <a:t>The AI severity scores fail a basic usefulness check</a:t>
+              <a:t>How robust is the average? Extreme firms change it substantially</a:t>
             </a:r>
           </a:p>
         </p:txBody>
       </p:sp>
       <p:pic>
         <p:nvPicPr>
-          <p:cNvPr id="3" name="Picture 2" descr="risk_score_audit.png"/>
+          <p:cNvPr id="3" name="Picture 2" descr="outlier_story.png"/>
           <p:cNvPicPr>
             <a:picLocks noChangeAspect="1"/>
           </p:cNvPicPr>
@@ -5584,7 +5564,7 @@
         <p:spPr>
           <a:xfrm>
             <a:off x="365760" y="1234440"/>
-            <a:ext cx="7498079" cy="3332479"/>
+            <a:ext cx="7498079" cy="4165600"/>
           </a:xfrm>
           <a:prstGeom prst="rect">
             <a:avLst/>
@@ -5615,7 +5595,7 @@
           <a:p>
             <a:pPr>
               <a:spcAft>
-                <a:spcPts val="1200"/>
+                <a:spcPts val="800"/>
               </a:spcAft>
               <a:defRPr sz="2000">
                 <a:solidFill>
@@ -5624,13 +5604,13 @@
               </a:defRPr>
             </a:pPr>
             <a:r>
-              <a:t>Every industrial record has score 5.</a:t>
+              <a:t>43 company-average ROEs.</a:t>
             </a:r>
           </a:p>
           <a:p>
             <a:pPr>
               <a:spcAft>
-                <a:spcPts val="1200"/>
+                <a:spcPts val="800"/>
               </a:spcAft>
               <a:defRPr sz="2000">
                 <a:solidFill>
@@ -5639,13 +5619,13 @@
               </a:defRPr>
             </a:pPr>
             <a:r>
-              <a:t>No score variation means no severity ranking or score–ROE correlation.</a:t>
+              <a:t>Full mean: 20.74%.</a:t>
             </a:r>
           </a:p>
           <a:p>
             <a:pPr>
               <a:spcAft>
-                <a:spcPts val="1200"/>
+                <a:spcPts val="800"/>
               </a:spcAft>
               <a:defRPr sz="2000">
                 <a:solidFill>
@@ -5654,7 +5634,37 @@
               </a:defRPr>
             </a:pPr>
             <a:r>
-              <a:t>The model scores require a rubric and human validation.</a:t>
+              <a:t>Full median: 14.93%.</a:t>
+            </a:r>
+          </a:p>
+          <a:p>
+            <a:pPr>
+              <a:spcAft>
+                <a:spcPts val="800"/>
+              </a:spcAft>
+              <a:defRPr sz="2000">
+                <a:solidFill>
+                  <a:srgbClr val="25364A"/>
+                </a:solidFill>
+              </a:defRPr>
+            </a:pPr>
+            <a:r>
+              <a:t>After ROE IQR exclusions: mean 13.50%.</a:t>
+            </a:r>
+          </a:p>
+          <a:p>
+            <a:pPr>
+              <a:spcAft>
+                <a:spcPts val="800"/>
+              </a:spcAft>
+              <a:defRPr sz="2000">
+                <a:solidFill>
+                  <a:srgbClr val="25364A"/>
+                </a:solidFill>
+              </a:defRPr>
+            </a:pPr>
+            <a:r>
+              <a:t>Keep extremes visible; use trimming as a sensitivity check.</a:t>
             </a:r>
           </a:p>
         </p:txBody>
@@ -5683,7 +5693,7 @@
           <a:p>
             <a:pPr>
               <a:spcAft>
-                <a:spcPts val="1200"/>
+                <a:spcPts val="800"/>
               </a:spcAft>
               <a:defRPr sz="1100">
                 <a:solidFill>
@@ -5692,7 +5702,7 @@
               </a:defRPr>
             </a:pPr>
             <a:r>
-              <a:t>Read-only audit of partner output • 472 records ≠ 472 independent companies</a:t>
+              <a:t>Methods: 1.5-IQR sensitivity • Company averages, not 2025-only values • Outlier does not mean error</a:t>
             </a:r>
           </a:p>
         </p:txBody>
@@ -5721,7 +5731,7 @@
           <a:p>
             <a:pPr>
               <a:spcAft>
-                <a:spcPts val="1200"/>
+                <a:spcPts val="800"/>
               </a:spcAft>
               <a:defRPr sz="1100">
                 <a:solidFill>
@@ -5777,7 +5787,7 @@
           <a:p>
             <a:pPr>
               <a:spcAft>
-                <a:spcPts val="1200"/>
+                <a:spcPts val="800"/>
               </a:spcAft>
               <a:defRPr sz="2900">
                 <a:solidFill>
@@ -5786,21 +5796,45 @@
               </a:defRPr>
             </a:pPr>
             <a:r>
-              <a:t>Tie supply-chain monitoring to a measurable financial pathway</a:t>
-            </a:r>
-          </a:p>
-        </p:txBody>
-      </p:sp>
-      <p:sp>
-        <p:nvSpPr>
-          <p:cNvPr id="3" name="TextBox 2"/>
+              <a:t>What might explain the pattern? Pfizer documents demand pressure</a:t>
+            </a:r>
+          </a:p>
+        </p:txBody>
+      </p:sp>
+      <p:pic>
+        <p:nvPicPr>
+          <p:cNvPr id="3" name="Picture 2" descr="pfizer_bridge.png"/>
+          <p:cNvPicPr>
+            <a:picLocks noChangeAspect="1"/>
+          </p:cNvPicPr>
+          <p:nvPr/>
+        </p:nvPicPr>
+        <p:blipFill>
+          <a:blip r:embed="rId2"/>
+          <a:stretch>
+            <a:fillRect/>
+          </a:stretch>
+        </p:blipFill>
+        <p:spPr>
+          <a:xfrm>
+            <a:off x="365760" y="1234440"/>
+            <a:ext cx="7498079" cy="3749039"/>
+          </a:xfrm>
+          <a:prstGeom prst="rect">
+            <a:avLst/>
+          </a:prstGeom>
+        </p:spPr>
+      </p:pic>
+      <p:sp>
+        <p:nvSpPr>
+          <p:cNvPr id="4" name="TextBox 3"/>
           <p:cNvSpPr txBox="1"/>
           <p:nvPr/>
         </p:nvSpPr>
         <p:spPr>
           <a:xfrm>
-            <a:off x="731520" y="1417320"/>
-            <a:ext cx="10698480" cy="4526280"/>
+            <a:off x="8046720" y="1463040"/>
+            <a:ext cx="3566160" cy="4480560"/>
           </a:xfrm>
           <a:prstGeom prst="rect">
             <a:avLst/>
@@ -5815,68 +5849,68 @@
           <a:p>
             <a:pPr>
               <a:spcAft>
-                <a:spcPts val="1200"/>
+                <a:spcPts val="800"/>
               </a:spcAft>
-              <a:defRPr sz="2300">
+              <a:defRPr sz="2000">
                 <a:solidFill>
                   <a:srgbClr val="25364A"/>
                 </a:solidFill>
               </a:defRPr>
             </a:pPr>
             <a:r>
-              <a:t>HEALTHCARE: demand forecast misses → excess inventory/write-offs → pressure on margin and asset use.</a:t>
+              <a:t>2023 filing: lower COVID-product demand and significant inventory write-offs.</a:t>
             </a:r>
           </a:p>
           <a:p>
             <a:pPr>
               <a:spcAft>
-                <a:spcPts val="1200"/>
+                <a:spcPts val="800"/>
               </a:spcAft>
-              <a:defRPr sz="2300">
+              <a:defRPr sz="2000">
                 <a:solidFill>
                   <a:srgbClr val="25364A"/>
                 </a:solidFill>
               </a:defRPr>
             </a:pPr>
             <a:r>
-              <a:t>Monitor: forecast error, inventory aging, write-offs and sales mix.</a:t>
+              <a:t>These provide business context for the margin and turnover declines.</a:t>
             </a:r>
           </a:p>
           <a:p>
             <a:pPr>
               <a:spcAft>
-                <a:spcPts val="1200"/>
+                <a:spcPts val="800"/>
               </a:spcAft>
-              <a:defRPr sz="2300">
+              <a:defRPr sz="2000">
                 <a:solidFill>
                   <a:srgbClr val="25364A"/>
                 </a:solidFill>
               </a:defRPr>
             </a:pPr>
             <a:r>
-              <a:t>INDUSTRIALS: input interruption or inflation → delayed production / higher costs → potential turnover or margin pressure.</a:t>
+              <a:t>Seagen acquisition also changed the asset base.</a:t>
             </a:r>
           </a:p>
           <a:p>
             <a:pPr>
               <a:spcAft>
-                <a:spcPts val="1200"/>
+                <a:spcPts val="800"/>
               </a:spcAft>
-              <a:defRPr sz="2300">
+              <a:defRPr sz="2000">
                 <a:solidFill>
                   <a:srgbClr val="25364A"/>
                 </a:solidFill>
               </a:defRPr>
             </a:pPr>
             <a:r>
-              <a:t>Monitor: critical single-source exposure, supplier delivery, work-in-process aging and cost pass-through.</a:t>
-            </a:r>
-          </a:p>
-        </p:txBody>
-      </p:sp>
-      <p:sp>
-        <p:nvSpPr>
-          <p:cNvPr id="4" name="TextBox 3"/>
+              <a:t>The bridge does not assign causal effects to those events.</a:t>
+            </a:r>
+          </a:p>
+        </p:txBody>
+      </p:sp>
+      <p:sp>
+        <p:nvSpPr>
+          <p:cNvPr id="5" name="TextBox 4"/>
           <p:cNvSpPr txBox="1"/>
           <p:nvPr/>
         </p:nvSpPr>
@@ -5898,7 +5932,7 @@
           <a:p>
             <a:pPr>
               <a:spcAft>
-                <a:spcPts val="1200"/>
+                <a:spcPts val="800"/>
               </a:spcAft>
               <a:defRPr sz="1100">
                 <a:solidFill>
@@ -5907,14 +5941,14 @@
               </a:defRPr>
             </a:pPr>
             <a:r>
-              <a:t>Proposed ERM dashboard • Operational KPIs require additional data; not claimed as observed results</a:t>
-            </a:r>
-          </a:p>
-        </p:txBody>
-      </p:sp>
-      <p:sp>
-        <p:nvSpPr>
-          <p:cNvPr id="5" name="TextBox 4"/>
+              <a:t>Q3: Business evidence • Pfizer 2023 10-K + financial panel • Reported events, not estimated causal effects</a:t>
+            </a:r>
+          </a:p>
+        </p:txBody>
+      </p:sp>
+      <p:sp>
+        <p:nvSpPr>
+          <p:cNvPr id="6" name="TextBox 5"/>
           <p:cNvSpPr txBox="1"/>
           <p:nvPr/>
         </p:nvSpPr>
@@ -5936,7 +5970,7 @@
           <a:p>
             <a:pPr>
               <a:spcAft>
-                <a:spcPts val="1200"/>
+                <a:spcPts val="800"/>
               </a:spcAft>
               <a:defRPr sz="1100">
                 <a:solidFill>
@@ -5992,7 +6026,7 @@
           <a:p>
             <a:pPr>
               <a:spcAft>
-                <a:spcPts val="1200"/>
+                <a:spcPts val="800"/>
               </a:spcAft>
               <a:defRPr sz="2900">
                 <a:solidFill>
@@ -6001,7 +6035,7 @@
               </a:defRPr>
             </a:pPr>
             <a:r>
-              <a:t>Evaluate management actions using outcomes, not promises</a:t>
+              <a:t>Industrial comparison: disclosed exposure need not mean disruption</a:t>
             </a:r>
           </a:p>
         </p:txBody>
@@ -6030,61 +6064,61 @@
           <a:p>
             <a:pPr>
               <a:spcAft>
-                <a:spcPts val="1200"/>
+                <a:spcPts val="800"/>
               </a:spcAft>
-              <a:defRPr sz="2300">
+              <a:defRPr sz="2100">
                 <a:solidFill>
                   <a:srgbClr val="25364A"/>
                 </a:solidFill>
               </a:defRPr>
             </a:pPr>
             <a:r>
-              <a:t>PFIZER — Reported action: cost realignment program announced in 2023. The filing expected at least $4bn in net savings, primarily in 2023–2024.</a:t>
+              <a:t>3M Item 1A: limited- or sole-source suppliers create operating exposure.</a:t>
             </a:r>
           </a:p>
           <a:p>
             <a:pPr>
               <a:spcAft>
-                <a:spcPts val="1200"/>
+                <a:spcPts val="800"/>
               </a:spcAft>
-              <a:defRPr sz="2300">
+              <a:defRPr sz="2100">
                 <a:solidFill>
                   <a:srgbClr val="25364A"/>
                 </a:solidFill>
               </a:defRPr>
             </a:pPr>
             <a:r>
-              <a:t>Follow-up: distinguish expected savings from realized savings, implementation costs and revenue changes.</a:t>
+              <a:t>2024 discussion: global supply chains stabilized, while feedstock and labor inflation persisted.</a:t>
             </a:r>
           </a:p>
           <a:p>
             <a:pPr>
               <a:spcAft>
-                <a:spcPts val="1200"/>
+                <a:spcPts val="800"/>
               </a:spcAft>
-              <a:defRPr sz="2300">
+              <a:defRPr sz="2100">
                 <a:solidFill>
                   <a:srgbClr val="25364A"/>
                 </a:solidFill>
               </a:defRPr>
             </a:pPr>
             <a:r>
-              <a:t>3M — Reported action: negotiated contracts and purchasing scale; the filing describes partial price-risk mitigation.</a:t>
+              <a:t>Reported response: negotiated contracts and purchasing scale partially mitigated price risk.</a:t>
             </a:r>
           </a:p>
           <a:p>
             <a:pPr>
               <a:spcAft>
-                <a:spcPts val="1200"/>
+                <a:spcPts val="800"/>
               </a:spcAft>
-              <a:defRPr sz="2300">
+              <a:defRPr sz="2100">
                 <a:solidFill>
                   <a:srgbClr val="25364A"/>
                 </a:solidFill>
               </a:defRPr>
             </a:pPr>
             <a:r>
-              <a:t>Follow-up: check costs, service levels and concentration—not merely whether contracts exist.</a:t>
+              <a:t>Implication: monitor actual delivery and costs alongside the risk disclosure.</a:t>
             </a:r>
           </a:p>
         </p:txBody>
@@ -6113,7 +6147,7 @@
           <a:p>
             <a:pPr>
               <a:spcAft>
-                <a:spcPts val="1200"/>
+                <a:spcPts val="800"/>
               </a:spcAft>
               <a:defRPr sz="1100">
                 <a:solidFill>
@@ -6122,7 +6156,7 @@
               </a:defRPr>
             </a:pPr>
             <a:r>
-              <a:t>Separate reported actions, management expectations, and our proposed follow-up</a:t>
+              <a:t>Q3: Business evidence • Verified industrial case • No claim of sector-wide prevalence or sector correlation</a:t>
             </a:r>
           </a:p>
         </p:txBody>
@@ -6151,7 +6185,7 @@
           <a:p>
             <a:pPr>
               <a:spcAft>
-                <a:spcPts val="1200"/>
+                <a:spcPts val="800"/>
               </a:spcAft>
               <a:defRPr sz="1100">
                 <a:solidFill>
@@ -6207,7 +6241,7 @@
           <a:p>
             <a:pPr>
               <a:spcAft>
-                <a:spcPts val="1200"/>
+                <a:spcPts val="800"/>
               </a:spcAft>
               <a:defRPr sz="2900">
                 <a:solidFill>
@@ -6216,45 +6250,21 @@
               </a:defRPr>
             </a:pPr>
             <a:r>
-              <a:t>A few extreme profiles materially change the average</a:t>
-            </a:r>
-          </a:p>
-        </p:txBody>
-      </p:sp>
-      <p:pic>
-        <p:nvPicPr>
-          <p:cNvPr id="3" name="Picture 2" descr="outlier_story.png"/>
-          <p:cNvPicPr>
-            <a:picLocks noChangeAspect="1"/>
-          </p:cNvPicPr>
-          <p:nvPr/>
-        </p:nvPicPr>
-        <p:blipFill>
-          <a:blip r:embed="rId2"/>
-          <a:stretch>
-            <a:fillRect/>
-          </a:stretch>
-        </p:blipFill>
-        <p:spPr>
-          <a:xfrm>
-            <a:off x="365760" y="1234440"/>
-            <a:ext cx="7498079" cy="4165600"/>
-          </a:xfrm>
-          <a:prstGeom prst="rect">
-            <a:avLst/>
-          </a:prstGeom>
-        </p:spPr>
-      </p:pic>
-      <p:sp>
-        <p:nvSpPr>
-          <p:cNvPr id="4" name="TextBox 3"/>
+              <a:t>Do risk disclosures distinguish high and low ROE? Still under review</a:t>
+            </a:r>
+          </a:p>
+        </p:txBody>
+      </p:sp>
+      <p:sp>
+        <p:nvSpPr>
+          <p:cNvPr id="3" name="TextBox 2"/>
           <p:cNvSpPr txBox="1"/>
           <p:nvPr/>
         </p:nvSpPr>
         <p:spPr>
           <a:xfrm>
-            <a:off x="8046720" y="1463040"/>
-            <a:ext cx="3566160" cy="4480560"/>
+            <a:off x="731520" y="1417320"/>
+            <a:ext cx="10698480" cy="4526280"/>
           </a:xfrm>
           <a:prstGeom prst="rect">
             <a:avLst/>
@@ -6269,53 +6279,68 @@
           <a:p>
             <a:pPr>
               <a:spcAft>
-                <a:spcPts val="1200"/>
+                <a:spcPts val="800"/>
               </a:spcAft>
-              <a:defRPr sz="2000">
+              <a:defRPr sz="2100">
                 <a:solidFill>
                   <a:srgbClr val="25364A"/>
                 </a:solidFill>
               </a:defRPr>
             </a:pPr>
             <a:r>
-              <a:t>Original rule: 1.5-IQR fences on company averages.</a:t>
+              <a:t>Design: highest 10 and lowest 10 ROEs in EACH year, 2020–2025.</a:t>
             </a:r>
           </a:p>
           <a:p>
             <a:pPr>
               <a:spcAft>
-                <a:spcPts val="1200"/>
+                <a:spcPts val="800"/>
               </a:spcAft>
-              <a:defRPr sz="2000">
+              <a:defRPr sz="2100">
                 <a:solidFill>
                   <a:srgbClr val="25364A"/>
                 </a:solidFill>
               </a:defRPr>
             </a:pPr>
             <a:r>
-              <a:t>The full-sample median is 14.93%.</a:t>
+              <a:t>120 selected company-years across 36 companies; 110 have matched Item 1A text.</a:t>
             </a:r>
           </a:p>
           <a:p>
             <a:pPr>
               <a:spcAft>
-                <a:spcPts val="1200"/>
+                <a:spcPts val="800"/>
               </a:spcAft>
-              <a:defRPr sz="2000">
+              <a:defRPr sz="2100">
                 <a:solidFill>
                   <a:srgbClr val="25364A"/>
                 </a:solidFill>
               </a:defRPr>
             </a:pPr>
             <a:r>
-              <a:t>Keep the full result; report trimmed means as sensitivity checks.</a:t>
-            </a:r>
-          </a:p>
-        </p:txBody>
-      </p:sp>
-      <p:sp>
-        <p:nvSpPr>
-          <p:cNvPr id="5" name="TextBox 4"/>
+              <a:t>AI task: quote risks, connect possible DuPont mechanisms, and identify alternative explanations.</a:t>
+            </a:r>
+          </a:p>
+          <a:p>
+            <a:pPr>
+              <a:spcAft>
+                <a:spcPts val="800"/>
+              </a:spcAft>
+              <a:defRPr sz="2100">
+                <a:solidFill>
+                  <a:srgbClr val="25364A"/>
+                </a:solidFill>
+              </a:defRPr>
+            </a:pPr>
+            <a:r>
+              <a:t>Answer pending: completed all-years API results have not yet been incorporated.</a:t>
+            </a:r>
+          </a:p>
+        </p:txBody>
+      </p:sp>
+      <p:sp>
+        <p:nvSpPr>
+          <p:cNvPr id="4" name="TextBox 3"/>
           <p:cNvSpPr txBox="1"/>
           <p:nvPr/>
         </p:nvSpPr>
@@ -6337,7 +6362,7 @@
           <a:p>
             <a:pPr>
               <a:spcAft>
-                <a:spcPts val="1200"/>
+                <a:spcPts val="800"/>
               </a:spcAft>
               <a:defRPr sz="1100">
                 <a:solidFill>
@@ -6346,14 +6371,14 @@
               </a:defRPr>
             </a:pPr>
             <a:r>
-              <a:t>Different exclusions define different populations • Outlier ≠ error • No causal claims</a:t>
-            </a:r>
-          </a:p>
-        </p:txBody>
-      </p:sp>
-      <p:sp>
-        <p:nvSpPr>
-          <p:cNvPr id="6" name="TextBox 5"/>
+              <a:t>Q3: Evidence gap • No invented AI results • Missingness and repeated firms limit inference</a:t>
+            </a:r>
+          </a:p>
+        </p:txBody>
+      </p:sp>
+      <p:sp>
+        <p:nvSpPr>
+          <p:cNvPr id="5" name="TextBox 4"/>
           <p:cNvSpPr txBox="1"/>
           <p:nvPr/>
         </p:nvSpPr>
@@ -6375,7 +6400,7 @@
           <a:p>
             <a:pPr>
               <a:spcAft>
-                <a:spcPts val="1200"/>
+                <a:spcPts val="800"/>
               </a:spcAft>
               <a:defRPr sz="1100">
                 <a:solidFill>

</xml_diff>